<commit_message>
cambios para crear los reportes de la inspeccion 21092020
</commit_message>
<xml_diff>
--- a/Docs/MODELO_DATOS_INVENTARIO.pptx
+++ b/Docs/MODELO_DATOS_INVENTARIO.pptx
@@ -107,7 +107,7 @@
   </p:defaultTextStyle>
   <p:extLst>
     <p:ext uri="{EFAFB233-063F-42B5-8137-9DF3F51BA10A}">
-      <p15:sldGuideLst xmlns="" xmlns:p15="http://schemas.microsoft.com/office/powerpoint/2012/main"/>
+      <p15:sldGuideLst xmlns:p15="http://schemas.microsoft.com/office/powerpoint/2012/main" xmlns=""/>
     </p:ext>
   </p:extLst>
 </p:presentation>
@@ -244,7 +244,7 @@
           <a:p>
             <a:fld id="{2DDBA0FF-ACFD-42C9-A4A3-E9ECDB2288AD}" type="datetimeFigureOut">
               <a:rPr lang="en-US" smtClean="0"/>
-              <a:t>9/9/2020</a:t>
+              <a:t>9/16/2020</a:t>
             </a:fld>
             <a:endParaRPr lang="en-US"/>
           </a:p>
@@ -414,7 +414,7 @@
           <a:p>
             <a:fld id="{2DDBA0FF-ACFD-42C9-A4A3-E9ECDB2288AD}" type="datetimeFigureOut">
               <a:rPr lang="en-US" smtClean="0"/>
-              <a:t>9/9/2020</a:t>
+              <a:t>9/16/2020</a:t>
             </a:fld>
             <a:endParaRPr lang="en-US"/>
           </a:p>
@@ -594,7 +594,7 @@
           <a:p>
             <a:fld id="{2DDBA0FF-ACFD-42C9-A4A3-E9ECDB2288AD}" type="datetimeFigureOut">
               <a:rPr lang="en-US" smtClean="0"/>
-              <a:t>9/9/2020</a:t>
+              <a:t>9/16/2020</a:t>
             </a:fld>
             <a:endParaRPr lang="en-US"/>
           </a:p>
@@ -764,7 +764,7 @@
           <a:p>
             <a:fld id="{2DDBA0FF-ACFD-42C9-A4A3-E9ECDB2288AD}" type="datetimeFigureOut">
               <a:rPr lang="en-US" smtClean="0"/>
-              <a:t>9/9/2020</a:t>
+              <a:t>9/16/2020</a:t>
             </a:fld>
             <a:endParaRPr lang="en-US"/>
           </a:p>
@@ -1010,7 +1010,7 @@
           <a:p>
             <a:fld id="{2DDBA0FF-ACFD-42C9-A4A3-E9ECDB2288AD}" type="datetimeFigureOut">
               <a:rPr lang="en-US" smtClean="0"/>
-              <a:t>9/9/2020</a:t>
+              <a:t>9/16/2020</a:t>
             </a:fld>
             <a:endParaRPr lang="en-US"/>
           </a:p>
@@ -1242,7 +1242,7 @@
           <a:p>
             <a:fld id="{2DDBA0FF-ACFD-42C9-A4A3-E9ECDB2288AD}" type="datetimeFigureOut">
               <a:rPr lang="en-US" smtClean="0"/>
-              <a:t>9/9/2020</a:t>
+              <a:t>9/16/2020</a:t>
             </a:fld>
             <a:endParaRPr lang="en-US"/>
           </a:p>
@@ -1609,7 +1609,7 @@
           <a:p>
             <a:fld id="{2DDBA0FF-ACFD-42C9-A4A3-E9ECDB2288AD}" type="datetimeFigureOut">
               <a:rPr lang="en-US" smtClean="0"/>
-              <a:t>9/9/2020</a:t>
+              <a:t>9/16/2020</a:t>
             </a:fld>
             <a:endParaRPr lang="en-US"/>
           </a:p>
@@ -1727,7 +1727,7 @@
           <a:p>
             <a:fld id="{2DDBA0FF-ACFD-42C9-A4A3-E9ECDB2288AD}" type="datetimeFigureOut">
               <a:rPr lang="en-US" smtClean="0"/>
-              <a:t>9/9/2020</a:t>
+              <a:t>9/16/2020</a:t>
             </a:fld>
             <a:endParaRPr lang="en-US"/>
           </a:p>
@@ -1822,7 +1822,7 @@
           <a:p>
             <a:fld id="{2DDBA0FF-ACFD-42C9-A4A3-E9ECDB2288AD}" type="datetimeFigureOut">
               <a:rPr lang="en-US" smtClean="0"/>
-              <a:t>9/9/2020</a:t>
+              <a:t>9/16/2020</a:t>
             </a:fld>
             <a:endParaRPr lang="en-US"/>
           </a:p>
@@ -2099,7 +2099,7 @@
           <a:p>
             <a:fld id="{2DDBA0FF-ACFD-42C9-A4A3-E9ECDB2288AD}" type="datetimeFigureOut">
               <a:rPr lang="en-US" smtClean="0"/>
-              <a:t>9/9/2020</a:t>
+              <a:t>9/16/2020</a:t>
             </a:fld>
             <a:endParaRPr lang="en-US"/>
           </a:p>
@@ -2352,7 +2352,7 @@
           <a:p>
             <a:fld id="{2DDBA0FF-ACFD-42C9-A4A3-E9ECDB2288AD}" type="datetimeFigureOut">
               <a:rPr lang="en-US" smtClean="0"/>
-              <a:t>9/9/2020</a:t>
+              <a:t>9/16/2020</a:t>
             </a:fld>
             <a:endParaRPr lang="en-US"/>
           </a:p>
@@ -2565,7 +2565,7 @@
           <a:p>
             <a:fld id="{2DDBA0FF-ACFD-42C9-A4A3-E9ECDB2288AD}" type="datetimeFigureOut">
               <a:rPr lang="en-US" smtClean="0"/>
-              <a:t>9/9/2020</a:t>
+              <a:t>9/16/2020</a:t>
             </a:fld>
             <a:endParaRPr lang="en-US"/>
           </a:p>
@@ -3753,13 +3753,18 @@
           </a:p>
           <a:p>
             <a:r>
-              <a:rPr lang="es-MX" sz="1050" b="1" dirty="0" smtClean="0">
+              <a:rPr lang="es-MX" sz="1050" b="1" smtClean="0">
                 <a:solidFill>
                   <a:srgbClr val="00B050"/>
                 </a:solidFill>
               </a:rPr>
-              <a:t>ESTATUS</a:t>
-            </a:r>
+              <a:t>K_ESTATUS</a:t>
+            </a:r>
+            <a:endParaRPr lang="es-MX" sz="1050" b="1" dirty="0" smtClean="0">
+              <a:solidFill>
+                <a:srgbClr val="00B050"/>
+              </a:solidFill>
+            </a:endParaRPr>
           </a:p>
           <a:p>
             <a:r>
@@ -4367,7 +4372,7 @@
   <a:extraClrSchemeLst/>
   <a:extLst>
     <a:ext uri="{05A4C25C-085E-4340-85A3-A5531E510DB2}">
-      <thm15:themeFamily xmlns="" xmlns:thm15="http://schemas.microsoft.com/office/thememl/2012/main" name="Office Theme" id="{62F939B6-93AF-4DB8-9C6B-D6C7DFDC589F}" vid="{4A3C46E8-61CC-4603-A589-7422A47A8E4A}"/>
+      <thm15:themeFamily xmlns:thm15="http://schemas.microsoft.com/office/thememl/2012/main" xmlns="" name="Office Theme" id="{62F939B6-93AF-4DB8-9C6B-D6C7DFDC589F}" vid="{4A3C46E8-61CC-4603-A589-7422A47A8E4A}"/>
     </a:ext>
   </a:extLst>
 </a:theme>

</xml_diff>